<commit_message>
Update annual strategic revenue target from 6.85M to 1.527M SAR and recalculate all BSC achievement rates
</commit_message>
<xml_diff>
--- a/التقرير_الاحترافي_المطور/عرض_تقديمي_جمعية_طبيبي_النصف_سنوي_٢٠٢٦.pptx
+++ b/التقرير_الاحترافي_المطور/عرض_تقديمي_جمعية_طبيبي_النصف_سنوي_٢٠٢٦.pptx
@@ -5893,7 +5893,7 @@
           </a:solidFill>
           <a:ln w="25400">
             <a:solidFill>
-              <a:srgbClr val="D97706"/>
+              <a:srgbClr val="2E7D32"/>
             </a:solidFill>
           </a:ln>
         </p:spPr>
@@ -5957,13 +5957,13 @@
             <a:pPr algn="ctr">
               <a:defRPr sz="2600" b="1">
                 <a:solidFill>
-                  <a:srgbClr val="D97706"/>
+                  <a:srgbClr val="2E7D32"/>
                 </a:solidFill>
                 <a:latin typeface="Arial"/>
               </a:defRPr>
             </a:pPr>
             <a:r>
-              <a:t>٣٢.٩٦٪</a:t>
+              <a:t>٦٣.٠١٪</a:t>
             </a:r>
           </a:p>
           <a:p>
@@ -5976,11 +5976,11 @@
               </a:defRPr>
             </a:pPr>
             <a:r>
-              <a:t>٩.٨٩ من ٣٠ نقطة</a:t>
+              <a:t>١٨.٩٠ من ٣٠ نقطة</a:t>
             </a:r>
             <a:br/>
             <a:r>
-              <a:t>تحصيل ٥٨٢ ألف ر.س (+١٩٢٪ نمو سنوي)</a:t>
+              <a:t>تحصيل ٥٨٢ ألف ر.س (٧٦.٢٥٪ من H1)</a:t>
             </a:r>
           </a:p>
         </p:txBody>
@@ -6283,7 +6283,7 @@
               </a:defRPr>
             </a:pPr>
             <a:r>
-              <a:t>نسبة الإنجاز الاستراتيجي الإجمالية الموزونة: ٣٢.٧٢٪  |  التقييم العام المعتمد: يحتاج إلى تحسين جذري وإعادة ضبط مسار</a:t>
+              <a:t>نسبة الإنجاز الاستراتيجي الإجمالية الموزونة: ٤١.٧٣٪  |  التقييم العام المعتمد: يحتاج إلى تحسين جذري وإعادة ضبط مسار</a:t>
             </a:r>
           </a:p>
           <a:p>
@@ -6555,7 +6555,7 @@
                         </a:defRPr>
                       </a:pPr>
                       <a:r>
-                        <a:t>إجمالي الإيرادات الكلية للجمعية</a:t>
+                        <a:t>إجمالي الإيرادات الكلية (المعدلة)</a:t>
                       </a:r>
                     </a:p>
                   </a:txBody>
@@ -6579,7 +6579,7 @@
                         </a:defRPr>
                       </a:pPr>
                       <a:r>
-                        <a:t>٦,٨٤٦,٠٠٠ ر.س</a:t>
+                        <a:t>١,٥٢٧,٠٠٠ ر.س</a:t>
                       </a:r>
                     </a:p>
                   </a:txBody>
@@ -6603,7 +6603,7 @@
                         </a:defRPr>
                       </a:pPr>
                       <a:r>
-                        <a:t>٣,٤٢٣,٠٠٠ ر.س</a:t>
+                        <a:t>٧٦٣,٥٠٠ ر.س</a:t>
                       </a:r>
                     </a:p>
                   </a:txBody>
@@ -6651,7 +6651,7 @@
                         </a:defRPr>
                       </a:pPr>
                       <a:r>
-                        <a:t>١٧.٠١٪</a:t>
+                        <a:t>٧٦.٢٥٪</a:t>
                       </a:r>
                     </a:p>
                   </a:txBody>
@@ -6669,13 +6669,13 @@
                       <a:pPr algn="ctr">
                         <a:defRPr sz="1000" b="1">
                           <a:solidFill>
-                            <a:srgbClr val="D97706"/>
+                            <a:srgbClr val="C62828"/>
                           </a:solidFill>
                           <a:latin typeface="Arial"/>
                         </a:defRPr>
                       </a:pPr>
                       <a:r>
-                        <a:t>متأخر حرِج</a:t>
+                        <a:t>متقدم وجيد</a:t>
                       </a:r>
                     </a:p>
                   </a:txBody>

</xml_diff>

<commit_message>
Fix incorrect KPI card calculations and reconcile revenue vs expense budget metrics across all deliverables
</commit_message>
<xml_diff>
--- a/التقرير_الاحترافي_المطور/عرض_تقديمي_جمعية_طبيبي_النصف_سنوي_٢٠٢٦.pptx
+++ b/التقرير_الاحترافي_المطور/عرض_تقديمي_جمعية_طبيبي_النصف_سنوي_٢٠٢٦.pptx
@@ -8784,7 +8784,7 @@
                 <a:gridCol w="2145731"/>
                 <a:gridCol w="2145731"/>
               </a:tblGrid>
-              <a:tr h="548640">
+              <a:tr h="493776">
                 <a:tc>
                   <a:txBody>
                     <a:bodyPr/>
@@ -8906,7 +8906,7 @@
                   </a:tcPr>
                 </a:tc>
               </a:tr>
-              <a:tr h="548640">
+              <a:tr h="493776">
                 <a:tc>
                   <a:txBody>
                     <a:bodyPr/>
@@ -9016,7 +9016,7 @@
                   </a:tcPr>
                 </a:tc>
               </a:tr>
-              <a:tr h="548640">
+              <a:tr h="493776">
                 <a:tc>
                   <a:txBody>
                     <a:bodyPr/>
@@ -9126,7 +9126,7 @@
                   </a:tcPr>
                 </a:tc>
               </a:tr>
-              <a:tr h="548640">
+              <a:tr h="493776">
                 <a:tc>
                   <a:txBody>
                     <a:bodyPr/>
@@ -9236,7 +9236,7 @@
                   </a:tcPr>
                 </a:tc>
               </a:tr>
-              <a:tr h="548640">
+              <a:tr h="493776">
                 <a:tc>
                   <a:txBody>
                     <a:bodyPr/>
@@ -9346,7 +9346,7 @@
                   </a:tcPr>
                 </a:tc>
               </a:tr>
-              <a:tr h="548640">
+              <a:tr h="493776">
                 <a:tc>
                   <a:txBody>
                     <a:bodyPr/>
@@ -9456,7 +9456,7 @@
                   </a:tcPr>
                 </a:tc>
               </a:tr>
-              <a:tr h="548640">
+              <a:tr h="493776">
                 <a:tc>
                   <a:txBody>
                     <a:bodyPr/>
@@ -9566,7 +9566,7 @@
                   </a:tcPr>
                 </a:tc>
               </a:tr>
-              <a:tr h="548640">
+              <a:tr h="493776">
                 <a:tc>
                   <a:txBody>
                     <a:bodyPr/>
@@ -9676,7 +9676,7 @@
                   </a:tcPr>
                 </a:tc>
               </a:tr>
-              <a:tr h="548640">
+              <a:tr h="493776">
                 <a:tc>
                   <a:txBody>
                     <a:bodyPr/>
@@ -9691,7 +9691,7 @@
                         </a:defRPr>
                       </a:pPr>
                       <a:r>
-                        <a:t>الإجمالي العام للموازنة</a:t>
+                        <a:t>إجمالي موازنة الإيرادات التقديرية</a:t>
                       </a:r>
                     </a:p>
                   </a:txBody>
@@ -9715,7 +9715,7 @@
                         </a:defRPr>
                       </a:pPr>
                       <a:r>
-                        <a:t>٢,٩٨١,٧٥٠</a:t>
+                        <a:t>١,٥٢٧,٠٠٠</a:t>
                       </a:r>
                     </a:p>
                   </a:txBody>
@@ -9739,7 +9739,7 @@
                         </a:defRPr>
                       </a:pPr>
                       <a:r>
-                        <a:t>١,٠٦٠,٦٦٦.٠٠</a:t>
+                        <a:t>٥٨٢,١٦٧.٥٢</a:t>
                       </a:r>
                     </a:p>
                   </a:txBody>
@@ -9763,7 +9763,7 @@
                         </a:defRPr>
                       </a:pPr>
                       <a:r>
-                        <a:t>٣٥.٥٧٪</a:t>
+                        <a:t>٣٨.١٢٪</a:t>
                       </a:r>
                     </a:p>
                   </a:txBody>
@@ -9787,13 +9787,123 @@
                         </a:defRPr>
                       </a:pPr>
                       <a:r>
-                        <a:t>كفاءة مالية عالية مع الحاجة لرفع الصرف على المرضى</a:t>
+                        <a:t>تحقيق ٧٦.٢٥٪ من مستهدف H1 (٥٨٢ ألف من ٧٦٣ ألف)</a:t>
                       </a:r>
                     </a:p>
                   </a:txBody>
                   <a:tcPr>
                     <a:solidFill>
                       <a:srgbClr val="F0EBE1"/>
+                    </a:solidFill>
+                  </a:tcPr>
+                </a:tc>
+              </a:tr>
+              <a:tr h="493776">
+                <a:tc>
+                  <a:txBody>
+                    <a:bodyPr/>
+                    <a:lstStyle/>
+                    <a:p>
+                      <a:pPr algn="ctr">
+                        <a:defRPr sz="950">
+                          <a:latin typeface="Arial"/>
+                        </a:defRPr>
+                      </a:pPr>
+                      <a:r>
+                        <a:t>إجمالي موازنة المصروفات التقديرية</a:t>
+                      </a:r>
+                    </a:p>
+                  </a:txBody>
+                  <a:tcPr>
+                    <a:solidFill>
+                      <a:srgbClr val="FAF8F5"/>
+                    </a:solidFill>
+                  </a:tcPr>
+                </a:tc>
+                <a:tc>
+                  <a:txBody>
+                    <a:bodyPr/>
+                    <a:lstStyle/>
+                    <a:p>
+                      <a:pPr algn="ctr">
+                        <a:defRPr sz="950">
+                          <a:latin typeface="Arial"/>
+                        </a:defRPr>
+                      </a:pPr>
+                      <a:r>
+                        <a:t>١,٤٥٤,٧٥٠</a:t>
+                      </a:r>
+                    </a:p>
+                  </a:txBody>
+                  <a:tcPr>
+                    <a:solidFill>
+                      <a:srgbClr val="FAF8F5"/>
+                    </a:solidFill>
+                  </a:tcPr>
+                </a:tc>
+                <a:tc>
+                  <a:txBody>
+                    <a:bodyPr/>
+                    <a:lstStyle/>
+                    <a:p>
+                      <a:pPr algn="ctr">
+                        <a:defRPr sz="950">
+                          <a:latin typeface="Arial"/>
+                        </a:defRPr>
+                      </a:pPr>
+                      <a:r>
+                        <a:t>٢٤٩,٢٧٤.٠٠</a:t>
+                      </a:r>
+                    </a:p>
+                  </a:txBody>
+                  <a:tcPr>
+                    <a:solidFill>
+                      <a:srgbClr val="FAF8F5"/>
+                    </a:solidFill>
+                  </a:tcPr>
+                </a:tc>
+                <a:tc>
+                  <a:txBody>
+                    <a:bodyPr/>
+                    <a:lstStyle/>
+                    <a:p>
+                      <a:pPr algn="ctr">
+                        <a:defRPr sz="950" b="1">
+                          <a:solidFill>
+                            <a:srgbClr val="2D2D2D"/>
+                          </a:solidFill>
+                          <a:latin typeface="Arial"/>
+                        </a:defRPr>
+                      </a:pPr>
+                      <a:r>
+                        <a:t>١٧.١٣٪</a:t>
+                      </a:r>
+                    </a:p>
+                  </a:txBody>
+                  <a:tcPr>
+                    <a:solidFill>
+                      <a:srgbClr val="FAF8F5"/>
+                    </a:solidFill>
+                  </a:tcPr>
+                </a:tc>
+                <a:tc>
+                  <a:txBody>
+                    <a:bodyPr/>
+                    <a:lstStyle/>
+                    <a:p>
+                      <a:pPr algn="ctr">
+                        <a:defRPr sz="950">
+                          <a:latin typeface="Arial"/>
+                        </a:defRPr>
+                      </a:pPr>
+                      <a:r>
+                        <a:t>تنفيذ ٣٤.٢٧٪ من موازنة النصف التشغيلية بانضباط تام</a:t>
+                      </a:r>
+                    </a:p>
+                  </a:txBody>
+                  <a:tcPr>
+                    <a:solidFill>
+                      <a:srgbClr val="FAF8F5"/>
                     </a:solidFill>
                   </a:tcPr>
                 </a:tc>

</xml_diff>

<commit_message>
Apply all user visual annotations on Strategic Matrix: 1.5M revenue target, remove deleted rows, and fix governance status
</commit_message>
<xml_diff>
--- a/التقرير_الاحترافي_المطور/عرض_تقديمي_جمعية_طبيبي_النصف_سنوي_٢٠٢٦.pptx
+++ b/التقرير_الاحترافي_المطور/عرض_تقديمي_جمعية_طبيبي_النصف_سنوي_٢٠٢٦.pptx
@@ -6394,7 +6394,7 @@
                 <a:gridCol w="1788109"/>
                 <a:gridCol w="1788110"/>
               </a:tblGrid>
-              <a:tr h="617220">
+              <a:tr h="493776">
                 <a:tc>
                   <a:txBody>
                     <a:bodyPr/>
@@ -6540,7 +6540,7 @@
                   </a:tcPr>
                 </a:tc>
               </a:tr>
-              <a:tr h="617220">
+              <a:tr h="493776">
                 <a:tc>
                   <a:txBody>
                     <a:bodyPr/>
@@ -6555,7 +6555,7 @@
                         </a:defRPr>
                       </a:pPr>
                       <a:r>
-                        <a:t>إجمالي الإيرادات الكلية (المعدلة)</a:t>
+                        <a:t>الإيرادات المالية الكلية (المعدلة)</a:t>
                       </a:r>
                     </a:p>
                   </a:txBody>
@@ -6579,7 +6579,7 @@
                         </a:defRPr>
                       </a:pPr>
                       <a:r>
-                        <a:t>١,٥٢٧,٠٠٠ ر.س</a:t>
+                        <a:t>١,٥٠٠,٠٠٠ ر.س</a:t>
                       </a:r>
                     </a:p>
                   </a:txBody>
@@ -6603,7 +6603,7 @@
                         </a:defRPr>
                       </a:pPr>
                       <a:r>
-                        <a:t>٧٦٣,٥٠٠ ر.س</a:t>
+                        <a:t>٧٥٠,٠٠٠ ر.س</a:t>
                       </a:r>
                     </a:p>
                   </a:txBody>
@@ -6651,7 +6651,7 @@
                         </a:defRPr>
                       </a:pPr>
                       <a:r>
-                        <a:t>٧٦.٢٥٪</a:t>
+                        <a:t>٧٧.٦٢٪</a:t>
                       </a:r>
                     </a:p>
                   </a:txBody>
@@ -6675,7 +6675,7 @@
                         </a:defRPr>
                       </a:pPr>
                       <a:r>
-                        <a:t>متقدم وجيد</a:t>
+                        <a:t>متقدم ومتميز</a:t>
                       </a:r>
                     </a:p>
                   </a:txBody>
@@ -6686,7 +6686,7 @@
                   </a:tcPr>
                 </a:tc>
               </a:tr>
-              <a:tr h="617220">
+              <a:tr h="493776">
                 <a:tc>
                   <a:txBody>
                     <a:bodyPr/>
@@ -6701,7 +6701,7 @@
                         </a:defRPr>
                       </a:pPr>
                       <a:r>
-                        <a:t>إيرادات الموازنة التشغيلية</a:t>
+                        <a:t>الاستشارات الطبية والدوائية</a:t>
                       </a:r>
                     </a:p>
                   </a:txBody>
@@ -6725,7 +6725,7 @@
                         </a:defRPr>
                       </a:pPr>
                       <a:r>
-                        <a:t>١,٥٢٧,٠٠٠ ر.س</a:t>
+                        <a:t>١,٢٠٠ استشارة</a:t>
                       </a:r>
                     </a:p>
                   </a:txBody>
@@ -6749,7 +6749,7 @@
                         </a:defRPr>
                       </a:pPr>
                       <a:r>
-                        <a:t>١,٥٢٧,٠٠٠ ر.س</a:t>
+                        <a:t>٦٠٠ استشارة</a:t>
                       </a:r>
                     </a:p>
                   </a:txBody>
@@ -6773,7 +6773,7 @@
                         </a:defRPr>
                       </a:pPr>
                       <a:r>
-                        <a:t>٥٨٢,١٦٧.٥٢ ر.س</a:t>
+                        <a:t>٠ استشارة</a:t>
                       </a:r>
                     </a:p>
                   </a:txBody>
@@ -6797,7 +6797,7 @@
                         </a:defRPr>
                       </a:pPr>
                       <a:r>
-                        <a:t>٣٨.١٢٪</a:t>
+                        <a:t>٠.٠٠٪</a:t>
                       </a:r>
                     </a:p>
                   </a:txBody>
@@ -6815,13 +6815,13 @@
                       <a:pPr algn="ctr">
                         <a:defRPr sz="1000" b="1">
                           <a:solidFill>
-                            <a:srgbClr val="D97706"/>
+                            <a:srgbClr val="C62828"/>
                           </a:solidFill>
                           <a:latin typeface="Arial"/>
                         </a:defRPr>
                       </a:pPr>
                       <a:r>
-                        <a:t>متأخر</a:t>
+                        <a:t>لم يبدأ</a:t>
                       </a:r>
                     </a:p>
                   </a:txBody>
@@ -6832,7 +6832,7 @@
                   </a:tcPr>
                 </a:tc>
               </a:tr>
-              <a:tr h="617220">
+              <a:tr h="493776">
                 <a:tc>
                   <a:txBody>
                     <a:bodyPr/>
@@ -6847,7 +6847,7 @@
                         </a:defRPr>
                       </a:pPr>
                       <a:r>
-                        <a:t>المساعدات العلاجية المباشرة</a:t>
+                        <a:t>الدراسات واستطلاعات الرأي</a:t>
                       </a:r>
                     </a:p>
                   </a:txBody>
@@ -6871,7 +6871,7 @@
                         </a:defRPr>
                       </a:pPr>
                       <a:r>
-                        <a:t>١,٥٠٠,٠٠٠ ر.س</a:t>
+                        <a:t>٦ دراسات</a:t>
                       </a:r>
                     </a:p>
                   </a:txBody>
@@ -6895,7 +6895,7 @@
                         </a:defRPr>
                       </a:pPr>
                       <a:r>
-                        <a:t>٧٥٠,٠٠٠ ر.س</a:t>
+                        <a:t>٣ دراسات</a:t>
                       </a:r>
                     </a:p>
                   </a:txBody>
@@ -6919,7 +6919,7 @@
                         </a:defRPr>
                       </a:pPr>
                       <a:r>
-                        <a:t>٢٠٨,٦٠٥.٠٠ ر.س</a:t>
+                        <a:t>٠ دراسة</a:t>
                       </a:r>
                     </a:p>
                   </a:txBody>
@@ -6943,7 +6943,7 @@
                         </a:defRPr>
                       </a:pPr>
                       <a:r>
-                        <a:t>٢٧.٨١٪</a:t>
+                        <a:t>٠.٠٠٪</a:t>
                       </a:r>
                     </a:p>
                   </a:txBody>
@@ -6961,13 +6961,13 @@
                       <a:pPr algn="ctr">
                         <a:defRPr sz="1000" b="1">
                           <a:solidFill>
-                            <a:srgbClr val="D97706"/>
+                            <a:srgbClr val="C62828"/>
                           </a:solidFill>
                           <a:latin typeface="Arial"/>
                         </a:defRPr>
                       </a:pPr>
                       <a:r>
-                        <a:t>متأخر حرِج</a:t>
+                        <a:t>لم يبدأ</a:t>
                       </a:r>
                     </a:p>
                   </a:txBody>
@@ -6978,7 +6978,7 @@
                   </a:tcPr>
                 </a:tc>
               </a:tr>
-              <a:tr h="617220">
+              <a:tr h="493776">
                 <a:tc>
                   <a:txBody>
                     <a:bodyPr/>
@@ -6993,7 +6993,7 @@
                         </a:defRPr>
                       </a:pPr>
                       <a:r>
-                        <a:t>عدد المستفيدين المخدومين</a:t>
+                        <a:t>ساعات وقيمة العمل التطوعي</a:t>
                       </a:r>
                     </a:p>
                   </a:txBody>
@@ -7017,7 +7017,7 @@
                         </a:defRPr>
                       </a:pPr>
                       <a:r>
-                        <a:t>٣٦,٦٠٦ مستفيد</a:t>
+                        <a:t>٣,٠٠٠ س (٢٠٢ ألف)</a:t>
                       </a:r>
                     </a:p>
                   </a:txBody>
@@ -7041,7 +7041,7 @@
                         </a:defRPr>
                       </a:pPr>
                       <a:r>
-                        <a:t>١٨,٣٠٣ مستفيد</a:t>
+                        <a:t>١,٥٠٠ س (١٠١ ألف)</a:t>
                       </a:r>
                     </a:p>
                   </a:txBody>
@@ -7065,7 +7065,7 @@
                         </a:defRPr>
                       </a:pPr>
                       <a:r>
-                        <a:t>٧ مستفيدين</a:t>
+                        <a:t>٤ فرص تطوعية</a:t>
                       </a:r>
                     </a:p>
                   </a:txBody>
@@ -7089,7 +7089,7 @@
                         </a:defRPr>
                       </a:pPr>
                       <a:r>
-                        <a:t>٠.٠٣٨٪</a:t>
+                        <a:t>غير مدققة</a:t>
                       </a:r>
                     </a:p>
                   </a:txBody>
@@ -7113,7 +7113,7 @@
                         </a:defRPr>
                       </a:pPr>
                       <a:r>
-                        <a:t>متعثر تماماً</a:t>
+                        <a:t>متعثر</a:t>
                       </a:r>
                     </a:p>
                   </a:txBody>
@@ -7124,7 +7124,7 @@
                   </a:tcPr>
                 </a:tc>
               </a:tr>
-              <a:tr h="617220">
+              <a:tr h="493776">
                 <a:tc>
                   <a:txBody>
                     <a:bodyPr/>
@@ -7139,7 +7139,7 @@
                         </a:defRPr>
                       </a:pPr>
                       <a:r>
-                        <a:t>الاستشارات الطبية والدوائية</a:t>
+                        <a:t>عقد الشراكات الصحية الفاعلة</a:t>
                       </a:r>
                     </a:p>
                   </a:txBody>
@@ -7163,7 +7163,7 @@
                         </a:defRPr>
                       </a:pPr>
                       <a:r>
-                        <a:t>١,٢٠٠ استشارة</a:t>
+                        <a:t>٩ شراكات</a:t>
                       </a:r>
                     </a:p>
                   </a:txBody>
@@ -7187,7 +7187,7 @@
                         </a:defRPr>
                       </a:pPr>
                       <a:r>
-                        <a:t>٦٠٠ استشارة</a:t>
+                        <a:t>٩ شراكات</a:t>
                       </a:r>
                     </a:p>
                   </a:txBody>
@@ -7211,7 +7211,7 @@
                         </a:defRPr>
                       </a:pPr>
                       <a:r>
-                        <a:t>٠ استشارة</a:t>
+                        <a:t>٩ شراكات مفعلة</a:t>
                       </a:r>
                     </a:p>
                   </a:txBody>
@@ -7235,7 +7235,299 @@
                         </a:defRPr>
                       </a:pPr>
                       <a:r>
-                        <a:t>٠.٠٠٪</a:t>
+                        <a:t>١٠٠.٠٠٪</a:t>
+                      </a:r>
+                    </a:p>
+                  </a:txBody>
+                  <a:tcPr>
+                    <a:solidFill>
+                      <a:srgbClr val="FAF8F5"/>
+                    </a:solidFill>
+                  </a:tcPr>
+                </a:tc>
+                <a:tc>
+                  <a:txBody>
+                    <a:bodyPr/>
+                    <a:lstStyle/>
+                    <a:p>
+                      <a:pPr algn="ctr">
+                        <a:defRPr sz="1000" b="1">
+                          <a:solidFill>
+                            <a:srgbClr val="2E7D32"/>
+                          </a:solidFill>
+                          <a:latin typeface="Arial"/>
+                        </a:defRPr>
+                      </a:pPr>
+                      <a:r>
+                        <a:t>مكتمل</a:t>
+                      </a:r>
+                    </a:p>
+                  </a:txBody>
+                  <a:tcPr>
+                    <a:solidFill>
+                      <a:srgbClr val="FAF8F5"/>
+                    </a:solidFill>
+                  </a:tcPr>
+                </a:tc>
+              </a:tr>
+              <a:tr h="493776">
+                <a:tc>
+                  <a:txBody>
+                    <a:bodyPr/>
+                    <a:lstStyle/>
+                    <a:p>
+                      <a:pPr algn="ctr">
+                        <a:defRPr sz="1000">
+                          <a:solidFill>
+                            <a:srgbClr val="2D2D2D"/>
+                          </a:solidFill>
+                          <a:latin typeface="Arial"/>
+                        </a:defRPr>
+                      </a:pPr>
+                      <a:r>
+                        <a:t>توطين الوظائف والكادر البشري</a:t>
+                      </a:r>
+                    </a:p>
+                  </a:txBody>
+                  <a:tcPr>
+                    <a:solidFill>
+                      <a:srgbClr val="FFFFFF"/>
+                    </a:solidFill>
+                  </a:tcPr>
+                </a:tc>
+                <a:tc>
+                  <a:txBody>
+                    <a:bodyPr/>
+                    <a:lstStyle/>
+                    <a:p>
+                      <a:pPr algn="ctr">
+                        <a:defRPr sz="1000">
+                          <a:solidFill>
+                            <a:srgbClr val="2D2D2D"/>
+                          </a:solidFill>
+                          <a:latin typeface="Arial"/>
+                        </a:defRPr>
+                      </a:pPr>
+                      <a:r>
+                        <a:t>١٠٠٪</a:t>
+                      </a:r>
+                    </a:p>
+                  </a:txBody>
+                  <a:tcPr>
+                    <a:solidFill>
+                      <a:srgbClr val="FFFFFF"/>
+                    </a:solidFill>
+                  </a:tcPr>
+                </a:tc>
+                <a:tc>
+                  <a:txBody>
+                    <a:bodyPr/>
+                    <a:lstStyle/>
+                    <a:p>
+                      <a:pPr algn="ctr">
+                        <a:defRPr sz="1000">
+                          <a:solidFill>
+                            <a:srgbClr val="2D2D2D"/>
+                          </a:solidFill>
+                          <a:latin typeface="Arial"/>
+                        </a:defRPr>
+                      </a:pPr>
+                      <a:r>
+                        <a:t>١٠٠٪</a:t>
+                      </a:r>
+                    </a:p>
+                  </a:txBody>
+                  <a:tcPr>
+                    <a:solidFill>
+                      <a:srgbClr val="FFFFFF"/>
+                    </a:solidFill>
+                  </a:tcPr>
+                </a:tc>
+                <a:tc>
+                  <a:txBody>
+                    <a:bodyPr/>
+                    <a:lstStyle/>
+                    <a:p>
+                      <a:pPr algn="ctr">
+                        <a:defRPr sz="1000">
+                          <a:solidFill>
+                            <a:srgbClr val="2D2D2D"/>
+                          </a:solidFill>
+                          <a:latin typeface="Arial"/>
+                        </a:defRPr>
+                      </a:pPr>
+                      <a:r>
+                        <a:t>١٠٠٪ (٣ موظفين)</a:t>
+                      </a:r>
+                    </a:p>
+                  </a:txBody>
+                  <a:tcPr>
+                    <a:solidFill>
+                      <a:srgbClr val="FFFFFF"/>
+                    </a:solidFill>
+                  </a:tcPr>
+                </a:tc>
+                <a:tc>
+                  <a:txBody>
+                    <a:bodyPr/>
+                    <a:lstStyle/>
+                    <a:p>
+                      <a:pPr algn="ctr">
+                        <a:defRPr sz="1000" b="1">
+                          <a:solidFill>
+                            <a:srgbClr val="2D2D2D"/>
+                          </a:solidFill>
+                          <a:latin typeface="Arial"/>
+                        </a:defRPr>
+                      </a:pPr>
+                      <a:r>
+                        <a:t>١٠٠.٠٠٪</a:t>
+                      </a:r>
+                    </a:p>
+                  </a:txBody>
+                  <a:tcPr>
+                    <a:solidFill>
+                      <a:srgbClr val="FFFFFF"/>
+                    </a:solidFill>
+                  </a:tcPr>
+                </a:tc>
+                <a:tc>
+                  <a:txBody>
+                    <a:bodyPr/>
+                    <a:lstStyle/>
+                    <a:p>
+                      <a:pPr algn="ctr">
+                        <a:defRPr sz="1000" b="1">
+                          <a:solidFill>
+                            <a:srgbClr val="2E7D32"/>
+                          </a:solidFill>
+                          <a:latin typeface="Arial"/>
+                        </a:defRPr>
+                      </a:pPr>
+                      <a:r>
+                        <a:t>مكتمل</a:t>
+                      </a:r>
+                    </a:p>
+                  </a:txBody>
+                  <a:tcPr>
+                    <a:solidFill>
+                      <a:srgbClr val="FFFFFF"/>
+                    </a:solidFill>
+                  </a:tcPr>
+                </a:tc>
+              </a:tr>
+              <a:tr h="493776">
+                <a:tc>
+                  <a:txBody>
+                    <a:bodyPr/>
+                    <a:lstStyle/>
+                    <a:p>
+                      <a:pPr algn="ctr">
+                        <a:defRPr sz="1000">
+                          <a:solidFill>
+                            <a:srgbClr val="2D2D2D"/>
+                          </a:solidFill>
+                          <a:latin typeface="Arial"/>
+                        </a:defRPr>
+                      </a:pPr>
+                      <a:r>
+                        <a:t>تدريب وتأهيل الكادر الإداري</a:t>
+                      </a:r>
+                    </a:p>
+                  </a:txBody>
+                  <a:tcPr>
+                    <a:solidFill>
+                      <a:srgbClr val="FAF8F5"/>
+                    </a:solidFill>
+                  </a:tcPr>
+                </a:tc>
+                <a:tc>
+                  <a:txBody>
+                    <a:bodyPr/>
+                    <a:lstStyle/>
+                    <a:p>
+                      <a:pPr algn="ctr">
+                        <a:defRPr sz="1000">
+                          <a:solidFill>
+                            <a:srgbClr val="2D2D2D"/>
+                          </a:solidFill>
+                          <a:latin typeface="Arial"/>
+                        </a:defRPr>
+                      </a:pPr>
+                      <a:r>
+                        <a:t>٤ دورات</a:t>
+                      </a:r>
+                    </a:p>
+                  </a:txBody>
+                  <a:tcPr>
+                    <a:solidFill>
+                      <a:srgbClr val="FAF8F5"/>
+                    </a:solidFill>
+                  </a:tcPr>
+                </a:tc>
+                <a:tc>
+                  <a:txBody>
+                    <a:bodyPr/>
+                    <a:lstStyle/>
+                    <a:p>
+                      <a:pPr algn="ctr">
+                        <a:defRPr sz="1000">
+                          <a:solidFill>
+                            <a:srgbClr val="2D2D2D"/>
+                          </a:solidFill>
+                          <a:latin typeface="Arial"/>
+                        </a:defRPr>
+                      </a:pPr>
+                      <a:r>
+                        <a:t>٢ دورة</a:t>
+                      </a:r>
+                    </a:p>
+                  </a:txBody>
+                  <a:tcPr>
+                    <a:solidFill>
+                      <a:srgbClr val="FAF8F5"/>
+                    </a:solidFill>
+                  </a:tcPr>
+                </a:tc>
+                <a:tc>
+                  <a:txBody>
+                    <a:bodyPr/>
+                    <a:lstStyle/>
+                    <a:p>
+                      <a:pPr algn="ctr">
+                        <a:defRPr sz="1000">
+                          <a:solidFill>
+                            <a:srgbClr val="2D2D2D"/>
+                          </a:solidFill>
+                          <a:latin typeface="Arial"/>
+                        </a:defRPr>
+                      </a:pPr>
+                      <a:r>
+                        <a:t>٨ دورات تدريبية</a:t>
+                      </a:r>
+                    </a:p>
+                  </a:txBody>
+                  <a:tcPr>
+                    <a:solidFill>
+                      <a:srgbClr val="FAF8F5"/>
+                    </a:solidFill>
+                  </a:tcPr>
+                </a:tc>
+                <a:tc>
+                  <a:txBody>
+                    <a:bodyPr/>
+                    <a:lstStyle/>
+                    <a:p>
+                      <a:pPr algn="ctr">
+                        <a:defRPr sz="1000" b="1">
+                          <a:solidFill>
+                            <a:srgbClr val="2D2D2D"/>
+                          </a:solidFill>
+                          <a:latin typeface="Arial"/>
+                        </a:defRPr>
+                      </a:pPr>
+                      <a:r>
+                        <a:t>٤٠٠.٠٠٪</a:t>
                       </a:r>
                     </a:p>
                   </a:txBody>
@@ -7259,7 +7551,7 @@
                         </a:defRPr>
                       </a:pPr>
                       <a:r>
-                        <a:t>لم يبدأ</a:t>
+                        <a:t>متقدم</a:t>
                       </a:r>
                     </a:p>
                   </a:txBody>
@@ -7270,7 +7562,7 @@
                   </a:tcPr>
                 </a:tc>
               </a:tr>
-              <a:tr h="617220">
+              <a:tr h="493776">
                 <a:tc>
                   <a:txBody>
                     <a:bodyPr/>
@@ -7285,7 +7577,7 @@
                         </a:defRPr>
                       </a:pPr>
                       <a:r>
-                        <a:t>عقد الشراكات الصحية الفاعلة</a:t>
+                        <a:t>التحول الرقمي والمحاسبي</a:t>
                       </a:r>
                     </a:p>
                   </a:txBody>
@@ -7309,7 +7601,7 @@
                         </a:defRPr>
                       </a:pPr>
                       <a:r>
-                        <a:t>٩ شراكات</a:t>
+                        <a:t>نظام سحابي</a:t>
                       </a:r>
                     </a:p>
                   </a:txBody>
@@ -7333,7 +7625,7 @@
                         </a:defRPr>
                       </a:pPr>
                       <a:r>
-                        <a:t>٩ شراكات</a:t>
+                        <a:t>نظام سحابي</a:t>
                       </a:r>
                     </a:p>
                   </a:txBody>
@@ -7357,7 +7649,7 @@
                         </a:defRPr>
                       </a:pPr>
                       <a:r>
-                        <a:t>٩ شراكات مفعلة</a:t>
+                        <a:t>تم تشغيل قيود</a:t>
                       </a:r>
                     </a:p>
                   </a:txBody>
@@ -7416,7 +7708,7 @@
                   </a:tcPr>
                 </a:tc>
               </a:tr>
-              <a:tr h="617220">
+              <a:tr h="493776">
                 <a:tc>
                   <a:txBody>
                     <a:bodyPr/>
@@ -7431,7 +7723,7 @@
                         </a:defRPr>
                       </a:pPr>
                       <a:r>
-                        <a:t>توطين الكادر وتطبيق قيود</a:t>
+                        <a:t>معايير الحوكمة ومنصة نوى</a:t>
                       </a:r>
                     </a:p>
                   </a:txBody>
@@ -7479,7 +7771,7 @@
                         </a:defRPr>
                       </a:pPr>
                       <a:r>
-                        <a:t>١٠٠٪</a:t>
+                        <a:t>بدء الملف</a:t>
                       </a:r>
                     </a:p>
                   </a:txBody>
@@ -7503,7 +7795,7 @@
                         </a:defRPr>
                       </a:pPr>
                       <a:r>
-                        <a:t>١٠٠٪ توطين + قيود</a:t>
+                        <a:t>قيد الاستعانة باستشاري</a:t>
                       </a:r>
                     </a:p>
                   </a:txBody>
@@ -7527,7 +7819,7 @@
                         </a:defRPr>
                       </a:pPr>
                       <a:r>
-                        <a:t>١٠٠.٠٠٪</a:t>
+                        <a:t>جاري العمل</a:t>
                       </a:r>
                     </a:p>
                   </a:txBody>
@@ -7545,13 +7837,13 @@
                       <a:pPr algn="ctr">
                         <a:defRPr sz="1000" b="1">
                           <a:solidFill>
-                            <a:srgbClr val="2E7D32"/>
+                            <a:srgbClr val="C62828"/>
                           </a:solidFill>
                           <a:latin typeface="Arial"/>
                         </a:defRPr>
                       </a:pPr>
                       <a:r>
-                        <a:t>مكتمل</a:t>
+                        <a:t>قيد التنفيذ</a:t>
                       </a:r>
                     </a:p>
                   </a:txBody>

</xml_diff>

<commit_message>
Update تنويع مصادر الدخل الذاتي to 100% across all deliverables and fix PPTX Slide 4 table layout
</commit_message>
<xml_diff>
--- a/التقرير_الاحترافي_المطور/عرض_تقديمي_جمعية_طبيبي_النصف_سنوي_٢٠٢٦.pptx
+++ b/التقرير_الاحترافي_المطور/عرض_تقديمي_جمعية_طبيبي_النصف_سنوي_٢٠٢٦.pptx
@@ -6394,7 +6394,7 @@
                 <a:gridCol w="1788109"/>
                 <a:gridCol w="1788110"/>
               </a:tblGrid>
-              <a:tr h="493776">
+              <a:tr h="448887">
                 <a:tc>
                   <a:txBody>
                     <a:bodyPr/>
@@ -6540,7 +6540,7 @@
                   </a:tcPr>
                 </a:tc>
               </a:tr>
-              <a:tr h="493776">
+              <a:tr h="448887">
                 <a:tc>
                   <a:txBody>
                     <a:bodyPr/>
@@ -6686,7 +6686,7 @@
                   </a:tcPr>
                 </a:tc>
               </a:tr>
-              <a:tr h="493776">
+              <a:tr h="448887">
                 <a:tc>
                   <a:txBody>
                     <a:bodyPr/>
@@ -6832,7 +6832,7 @@
                   </a:tcPr>
                 </a:tc>
               </a:tr>
-              <a:tr h="493776">
+              <a:tr h="448887">
                 <a:tc>
                   <a:txBody>
                     <a:bodyPr/>
@@ -6978,7 +6978,7 @@
                   </a:tcPr>
                 </a:tc>
               </a:tr>
-              <a:tr h="493776">
+              <a:tr h="448887">
                 <a:tc>
                   <a:txBody>
                     <a:bodyPr/>
@@ -7124,7 +7124,7 @@
                   </a:tcPr>
                 </a:tc>
               </a:tr>
-              <a:tr h="493776">
+              <a:tr h="448887">
                 <a:tc>
                   <a:txBody>
                     <a:bodyPr/>
@@ -7270,7 +7270,7 @@
                   </a:tcPr>
                 </a:tc>
               </a:tr>
-              <a:tr h="493776">
+              <a:tr h="448887">
                 <a:tc>
                   <a:txBody>
                     <a:bodyPr/>
@@ -7416,7 +7416,7 @@
                   </a:tcPr>
                 </a:tc>
               </a:tr>
-              <a:tr h="493776">
+              <a:tr h="448887">
                 <a:tc>
                   <a:txBody>
                     <a:bodyPr/>
@@ -7562,7 +7562,7 @@
                   </a:tcPr>
                 </a:tc>
               </a:tr>
-              <a:tr h="493776">
+              <a:tr h="448887">
                 <a:tc>
                   <a:txBody>
                     <a:bodyPr/>
@@ -7708,7 +7708,7 @@
                   </a:tcPr>
                 </a:tc>
               </a:tr>
-              <a:tr h="493776">
+              <a:tr h="448887">
                 <a:tc>
                   <a:txBody>
                     <a:bodyPr/>
@@ -7850,6 +7850,152 @@
                   <a:tcPr>
                     <a:solidFill>
                       <a:srgbClr val="FAF8F5"/>
+                    </a:solidFill>
+                  </a:tcPr>
+                </a:tc>
+              </a:tr>
+              <a:tr h="448890">
+                <a:tc>
+                  <a:txBody>
+                    <a:bodyPr/>
+                    <a:lstStyle/>
+                    <a:p>
+                      <a:pPr algn="ctr">
+                        <a:defRPr sz="1000">
+                          <a:solidFill>
+                            <a:srgbClr val="2D2D2D"/>
+                          </a:solidFill>
+                          <a:latin typeface="Arial"/>
+                        </a:defRPr>
+                      </a:pPr>
+                      <a:r>
+                        <a:t>تنويع مصادر الدخل الذاتي</a:t>
+                      </a:r>
+                    </a:p>
+                  </a:txBody>
+                  <a:tcPr>
+                    <a:solidFill>
+                      <a:srgbClr val="FFFFFF"/>
+                    </a:solidFill>
+                  </a:tcPr>
+                </a:tc>
+                <a:tc>
+                  <a:txBody>
+                    <a:bodyPr/>
+                    <a:lstStyle/>
+                    <a:p>
+                      <a:pPr algn="ctr">
+                        <a:defRPr sz="1000">
+                          <a:solidFill>
+                            <a:srgbClr val="2D2D2D"/>
+                          </a:solidFill>
+                          <a:latin typeface="Arial"/>
+                        </a:defRPr>
+                      </a:pPr>
+                      <a:r>
+                        <a:t>٦ مصادر</a:t>
+                      </a:r>
+                    </a:p>
+                  </a:txBody>
+                  <a:tcPr>
+                    <a:solidFill>
+                      <a:srgbClr val="FFFFFF"/>
+                    </a:solidFill>
+                  </a:tcPr>
+                </a:tc>
+                <a:tc>
+                  <a:txBody>
+                    <a:bodyPr/>
+                    <a:lstStyle/>
+                    <a:p>
+                      <a:pPr algn="ctr">
+                        <a:defRPr sz="1000">
+                          <a:solidFill>
+                            <a:srgbClr val="2D2D2D"/>
+                          </a:solidFill>
+                          <a:latin typeface="Arial"/>
+                        </a:defRPr>
+                      </a:pPr>
+                      <a:r>
+                        <a:t>٦ مصادر</a:t>
+                      </a:r>
+                    </a:p>
+                  </a:txBody>
+                  <a:tcPr>
+                    <a:solidFill>
+                      <a:srgbClr val="FFFFFF"/>
+                    </a:solidFill>
+                  </a:tcPr>
+                </a:tc>
+                <a:tc>
+                  <a:txBody>
+                    <a:bodyPr/>
+                    <a:lstStyle/>
+                    <a:p>
+                      <a:pPr algn="ctr">
+                        <a:defRPr sz="1000">
+                          <a:solidFill>
+                            <a:srgbClr val="2D2D2D"/>
+                          </a:solidFill>
+                          <a:latin typeface="Arial"/>
+                        </a:defRPr>
+                      </a:pPr>
+                      <a:r>
+                        <a:t>٦ مصادر نشطة</a:t>
+                      </a:r>
+                    </a:p>
+                  </a:txBody>
+                  <a:tcPr>
+                    <a:solidFill>
+                      <a:srgbClr val="FFFFFF"/>
+                    </a:solidFill>
+                  </a:tcPr>
+                </a:tc>
+                <a:tc>
+                  <a:txBody>
+                    <a:bodyPr/>
+                    <a:lstStyle/>
+                    <a:p>
+                      <a:pPr algn="ctr">
+                        <a:defRPr sz="1000" b="1">
+                          <a:solidFill>
+                            <a:srgbClr val="2D2D2D"/>
+                          </a:solidFill>
+                          <a:latin typeface="Arial"/>
+                        </a:defRPr>
+                      </a:pPr>
+                      <a:r>
+                        <a:t>١٠٠.٠٠٪</a:t>
+                      </a:r>
+                    </a:p>
+                  </a:txBody>
+                  <a:tcPr>
+                    <a:solidFill>
+                      <a:srgbClr val="FFFFFF"/>
+                    </a:solidFill>
+                  </a:tcPr>
+                </a:tc>
+                <a:tc>
+                  <a:txBody>
+                    <a:bodyPr/>
+                    <a:lstStyle/>
+                    <a:p>
+                      <a:pPr algn="ctr">
+                        <a:defRPr sz="1000" b="1">
+                          <a:solidFill>
+                            <a:srgbClr val="2E7D32"/>
+                          </a:solidFill>
+                          <a:latin typeface="Arial"/>
+                        </a:defRPr>
+                      </a:pPr>
+                      <a:r>
+                        <a:t>مكتمل</a:t>
+                      </a:r>
+                    </a:p>
+                  </a:txBody>
+                  <a:tcPr>
+                    <a:solidFill>
+                      <a:srgbClr val="FFFFFF"/>
                     </a:solidFill>
                   </a:tcPr>
                 </a:tc>

</xml_diff>

<commit_message>
Update معايير الحوكمة ومنصة نوى to 70% achievement rate and recalculate overall BSC score to 52.12%
</commit_message>
<xml_diff>
--- a/التقرير_الاحترافي_المطور/عرض_تقديمي_جمعية_طبيبي_النصف_سنوي_٢٠٢٦.pptx
+++ b/التقرير_الاحترافي_المطور/عرض_تقديمي_جمعية_طبيبي_النصف_سنوي_٢٠٢٦.pptx
@@ -6185,7 +6185,7 @@
               </a:defRPr>
             </a:pPr>
             <a:r>
-              <a:t>٦٠.٠٠٪</a:t>
+              <a:t>٩٢.٥٠٪</a:t>
             </a:r>
           </a:p>
           <a:p>
@@ -6198,11 +6198,11 @@
               </a:defRPr>
             </a:pPr>
             <a:r>
-              <a:t>٩.٠٠ من ١٥ نقطة</a:t>
+              <a:t>١٣.٨٨ من ١٥ نقطة</a:t>
             </a:r>
             <a:br/>
             <a:r>
-              <a:t>١٠٠٪ توطين وتطبيق نظام قيود السحابي</a:t>
+              <a:t>تحقيق ٧٠٪ من معايير الحوكمة و١٠٠٪ توطين</a:t>
             </a:r>
           </a:p>
         </p:txBody>
@@ -6283,7 +6283,7 @@
               </a:defRPr>
             </a:pPr>
             <a:r>
-              <a:t>نسبة الإنجاز الاستراتيجي الإجمالية الموزونة: ٤١.٧٣٪  |  التقييم العام المعتمد: يحتاج إلى تحسين جذري وإعادة ضبط مسار</a:t>
+              <a:t>نسبة الإنجاز الاستراتيجي الإجمالية الموزونة: ٥٢.١٢٪  |  التقييم العام المعتمد: يحتاج إلى تحسين جذري وإعادة ضبط مسار</a:t>
             </a:r>
           </a:p>
           <a:p>
@@ -7771,7 +7771,7 @@
                         </a:defRPr>
                       </a:pPr>
                       <a:r>
-                        <a:t>بدء الملف</a:t>
+                        <a:t>٥٠٪</a:t>
                       </a:r>
                     </a:p>
                   </a:txBody>
@@ -7795,7 +7795,7 @@
                         </a:defRPr>
                       </a:pPr>
                       <a:r>
-                        <a:t>قيد الاستعانة باستشاري</a:t>
+                        <a:t>استيفاء ٧٠٪ من المعايير</a:t>
                       </a:r>
                     </a:p>
                   </a:txBody>
@@ -7819,7 +7819,7 @@
                         </a:defRPr>
                       </a:pPr>
                       <a:r>
-                        <a:t>جاري العمل</a:t>
+                        <a:t>٧٠.٠٠٪</a:t>
                       </a:r>
                     </a:p>
                   </a:txBody>
@@ -7843,7 +7843,7 @@
                         </a:defRPr>
                       </a:pPr>
                       <a:r>
-                        <a:t>قيد التنفيذ</a:t>
+                        <a:t>متقدم</a:t>
                       </a:r>
                     </a:p>
                   </a:txBody>

</xml_diff>

<commit_message>
Update all remaining mentions of beneficiaries target from 36,606 to 200 (100 H1) across dashboard, word, pptx, and web slides
</commit_message>
<xml_diff>
--- a/التقرير_الاحترافي_المطور/عرض_تقديمي_جمعية_طبيبي_النصف_سنوي_٢٠٢٦.pptx
+++ b/التقرير_الاحترافي_المطور/عرض_تقديمي_جمعية_طبيبي_النصف_سنوي_٢٠٢٦.pptx
@@ -6394,7 +6394,7 @@
                 <a:gridCol w="1788109"/>
                 <a:gridCol w="1788110"/>
               </a:tblGrid>
-              <a:tr h="448887">
+              <a:tr h="411480">
                 <a:tc>
                   <a:txBody>
                     <a:bodyPr/>
@@ -6540,7 +6540,7 @@
                   </a:tcPr>
                 </a:tc>
               </a:tr>
-              <a:tr h="448887">
+              <a:tr h="411480">
                 <a:tc>
                   <a:txBody>
                     <a:bodyPr/>
@@ -6669,7 +6669,7 @@
                       <a:pPr algn="ctr">
                         <a:defRPr sz="1000" b="1">
                           <a:solidFill>
-                            <a:srgbClr val="C62828"/>
+                            <a:srgbClr val="2E7D32"/>
                           </a:solidFill>
                           <a:latin typeface="Arial"/>
                         </a:defRPr>
@@ -6686,7 +6686,7 @@
                   </a:tcPr>
                 </a:tc>
               </a:tr>
-              <a:tr h="448887">
+              <a:tr h="411480">
                 <a:tc>
                   <a:txBody>
                     <a:bodyPr/>
@@ -6701,7 +6701,7 @@
                         </a:defRPr>
                       </a:pPr>
                       <a:r>
-                        <a:t>الاستشارات الطبية والدوائية</a:t>
+                        <a:t>عدد المستفيدين المخدومين</a:t>
                       </a:r>
                     </a:p>
                   </a:txBody>
@@ -6725,7 +6725,7 @@
                         </a:defRPr>
                       </a:pPr>
                       <a:r>
-                        <a:t>١,٢٠٠ استشارة</a:t>
+                        <a:t>٢٠٠ مستفيد</a:t>
                       </a:r>
                     </a:p>
                   </a:txBody>
@@ -6749,7 +6749,7 @@
                         </a:defRPr>
                       </a:pPr>
                       <a:r>
-                        <a:t>٦٠٠ استشارة</a:t>
+                        <a:t>١٠٠ مستفيد</a:t>
                       </a:r>
                     </a:p>
                   </a:txBody>
@@ -6773,7 +6773,7 @@
                         </a:defRPr>
                       </a:pPr>
                       <a:r>
-                        <a:t>٠ استشارة</a:t>
+                        <a:t>٧ مستفيدين</a:t>
                       </a:r>
                     </a:p>
                   </a:txBody>
@@ -6797,13 +6797,159 @@
                         </a:defRPr>
                       </a:pPr>
                       <a:r>
+                        <a:t>٧.٠٠٪</a:t>
+                      </a:r>
+                    </a:p>
+                  </a:txBody>
+                  <a:tcPr>
+                    <a:solidFill>
+                      <a:srgbClr val="FFFFFF"/>
+                    </a:solidFill>
+                  </a:tcPr>
+                </a:tc>
+                <a:tc>
+                  <a:txBody>
+                    <a:bodyPr/>
+                    <a:lstStyle/>
+                    <a:p>
+                      <a:pPr algn="ctr">
+                        <a:defRPr sz="1000" b="1">
+                          <a:solidFill>
+                            <a:srgbClr val="D97706"/>
+                          </a:solidFill>
+                          <a:latin typeface="Arial"/>
+                        </a:defRPr>
+                      </a:pPr>
+                      <a:r>
+                        <a:t>متأخر</a:t>
+                      </a:r>
+                    </a:p>
+                  </a:txBody>
+                  <a:tcPr>
+                    <a:solidFill>
+                      <a:srgbClr val="FFFFFF"/>
+                    </a:solidFill>
+                  </a:tcPr>
+                </a:tc>
+              </a:tr>
+              <a:tr h="411480">
+                <a:tc>
+                  <a:txBody>
+                    <a:bodyPr/>
+                    <a:lstStyle/>
+                    <a:p>
+                      <a:pPr algn="ctr">
+                        <a:defRPr sz="1000">
+                          <a:solidFill>
+                            <a:srgbClr val="2D2D2D"/>
+                          </a:solidFill>
+                          <a:latin typeface="Arial"/>
+                        </a:defRPr>
+                      </a:pPr>
+                      <a:r>
+                        <a:t>الاستشارات الطبية والدوائية</a:t>
+                      </a:r>
+                    </a:p>
+                  </a:txBody>
+                  <a:tcPr>
+                    <a:solidFill>
+                      <a:srgbClr val="FAF8F5"/>
+                    </a:solidFill>
+                  </a:tcPr>
+                </a:tc>
+                <a:tc>
+                  <a:txBody>
+                    <a:bodyPr/>
+                    <a:lstStyle/>
+                    <a:p>
+                      <a:pPr algn="ctr">
+                        <a:defRPr sz="1000">
+                          <a:solidFill>
+                            <a:srgbClr val="2D2D2D"/>
+                          </a:solidFill>
+                          <a:latin typeface="Arial"/>
+                        </a:defRPr>
+                      </a:pPr>
+                      <a:r>
+                        <a:t>١,٢٠٠ استشارة</a:t>
+                      </a:r>
+                    </a:p>
+                  </a:txBody>
+                  <a:tcPr>
+                    <a:solidFill>
+                      <a:srgbClr val="FAF8F5"/>
+                    </a:solidFill>
+                  </a:tcPr>
+                </a:tc>
+                <a:tc>
+                  <a:txBody>
+                    <a:bodyPr/>
+                    <a:lstStyle/>
+                    <a:p>
+                      <a:pPr algn="ctr">
+                        <a:defRPr sz="1000">
+                          <a:solidFill>
+                            <a:srgbClr val="2D2D2D"/>
+                          </a:solidFill>
+                          <a:latin typeface="Arial"/>
+                        </a:defRPr>
+                      </a:pPr>
+                      <a:r>
+                        <a:t>٦٠٠ استشارة</a:t>
+                      </a:r>
+                    </a:p>
+                  </a:txBody>
+                  <a:tcPr>
+                    <a:solidFill>
+                      <a:srgbClr val="FAF8F5"/>
+                    </a:solidFill>
+                  </a:tcPr>
+                </a:tc>
+                <a:tc>
+                  <a:txBody>
+                    <a:bodyPr/>
+                    <a:lstStyle/>
+                    <a:p>
+                      <a:pPr algn="ctr">
+                        <a:defRPr sz="1000">
+                          <a:solidFill>
+                            <a:srgbClr val="2D2D2D"/>
+                          </a:solidFill>
+                          <a:latin typeface="Arial"/>
+                        </a:defRPr>
+                      </a:pPr>
+                      <a:r>
+                        <a:t>٠ استشارة</a:t>
+                      </a:r>
+                    </a:p>
+                  </a:txBody>
+                  <a:tcPr>
+                    <a:solidFill>
+                      <a:srgbClr val="FAF8F5"/>
+                    </a:solidFill>
+                  </a:tcPr>
+                </a:tc>
+                <a:tc>
+                  <a:txBody>
+                    <a:bodyPr/>
+                    <a:lstStyle/>
+                    <a:p>
+                      <a:pPr algn="ctr">
+                        <a:defRPr sz="1000" b="1">
+                          <a:solidFill>
+                            <a:srgbClr val="2D2D2D"/>
+                          </a:solidFill>
+                          <a:latin typeface="Arial"/>
+                        </a:defRPr>
+                      </a:pPr>
+                      <a:r>
                         <a:t>٠.٠٠٪</a:t>
                       </a:r>
                     </a:p>
                   </a:txBody>
                   <a:tcPr>
                     <a:solidFill>
-                      <a:srgbClr val="FFFFFF"/>
+                      <a:srgbClr val="FAF8F5"/>
                     </a:solidFill>
                   </a:tcPr>
                 </a:tc>
@@ -6827,12 +6973,12 @@
                   </a:txBody>
                   <a:tcPr>
                     <a:solidFill>
-                      <a:srgbClr val="FFFFFF"/>
+                      <a:srgbClr val="FAF8F5"/>
                     </a:solidFill>
                   </a:tcPr>
                 </a:tc>
               </a:tr>
-              <a:tr h="448887">
+              <a:tr h="411480">
                 <a:tc>
                   <a:txBody>
                     <a:bodyPr/>
@@ -6853,7 +6999,7 @@
                   </a:txBody>
                   <a:tcPr>
                     <a:solidFill>
-                      <a:srgbClr val="FAF8F5"/>
+                      <a:srgbClr val="FFFFFF"/>
                     </a:solidFill>
                   </a:tcPr>
                 </a:tc>
@@ -6877,7 +7023,7 @@
                   </a:txBody>
                   <a:tcPr>
                     <a:solidFill>
-                      <a:srgbClr val="FAF8F5"/>
+                      <a:srgbClr val="FFFFFF"/>
                     </a:solidFill>
                   </a:tcPr>
                 </a:tc>
@@ -6901,7 +7047,7 @@
                   </a:txBody>
                   <a:tcPr>
                     <a:solidFill>
-                      <a:srgbClr val="FAF8F5"/>
+                      <a:srgbClr val="FFFFFF"/>
                     </a:solidFill>
                   </a:tcPr>
                 </a:tc>
@@ -6925,7 +7071,7 @@
                   </a:txBody>
                   <a:tcPr>
                     <a:solidFill>
-                      <a:srgbClr val="FAF8F5"/>
+                      <a:srgbClr val="FFFFFF"/>
                     </a:solidFill>
                   </a:tcPr>
                 </a:tc>
@@ -6949,7 +7095,7 @@
                   </a:txBody>
                   <a:tcPr>
                     <a:solidFill>
-                      <a:srgbClr val="FAF8F5"/>
+                      <a:srgbClr val="FFFFFF"/>
                     </a:solidFill>
                   </a:tcPr>
                 </a:tc>
@@ -6973,12 +7119,12 @@
                   </a:txBody>
                   <a:tcPr>
                     <a:solidFill>
-                      <a:srgbClr val="FAF8F5"/>
+                      <a:srgbClr val="FFFFFF"/>
                     </a:solidFill>
                   </a:tcPr>
                 </a:tc>
               </a:tr>
-              <a:tr h="448887">
+              <a:tr h="411480">
                 <a:tc>
                   <a:txBody>
                     <a:bodyPr/>
@@ -6999,7 +7145,7 @@
                   </a:txBody>
                   <a:tcPr>
                     <a:solidFill>
-                      <a:srgbClr val="FFFFFF"/>
+                      <a:srgbClr val="FAF8F5"/>
                     </a:solidFill>
                   </a:tcPr>
                 </a:tc>
@@ -7023,7 +7169,7 @@
                   </a:txBody>
                   <a:tcPr>
                     <a:solidFill>
-                      <a:srgbClr val="FFFFFF"/>
+                      <a:srgbClr val="FAF8F5"/>
                     </a:solidFill>
                   </a:tcPr>
                 </a:tc>
@@ -7047,7 +7193,7 @@
                   </a:txBody>
                   <a:tcPr>
                     <a:solidFill>
-                      <a:srgbClr val="FFFFFF"/>
+                      <a:srgbClr val="FAF8F5"/>
                     </a:solidFill>
                   </a:tcPr>
                 </a:tc>
@@ -7071,7 +7217,7 @@
                   </a:txBody>
                   <a:tcPr>
                     <a:solidFill>
-                      <a:srgbClr val="FFFFFF"/>
+                      <a:srgbClr val="FAF8F5"/>
                     </a:solidFill>
                   </a:tcPr>
                 </a:tc>
@@ -7095,7 +7241,7 @@
                   </a:txBody>
                   <a:tcPr>
                     <a:solidFill>
-                      <a:srgbClr val="FFFFFF"/>
+                      <a:srgbClr val="FAF8F5"/>
                     </a:solidFill>
                   </a:tcPr>
                 </a:tc>
@@ -7119,12 +7265,12 @@
                   </a:txBody>
                   <a:tcPr>
                     <a:solidFill>
-                      <a:srgbClr val="FFFFFF"/>
+                      <a:srgbClr val="FAF8F5"/>
                     </a:solidFill>
                   </a:tcPr>
                 </a:tc>
               </a:tr>
-              <a:tr h="448887">
+              <a:tr h="411480">
                 <a:tc>
                   <a:txBody>
                     <a:bodyPr/>
@@ -7145,7 +7291,7 @@
                   </a:txBody>
                   <a:tcPr>
                     <a:solidFill>
-                      <a:srgbClr val="FAF8F5"/>
+                      <a:srgbClr val="FFFFFF"/>
                     </a:solidFill>
                   </a:tcPr>
                 </a:tc>
@@ -7169,7 +7315,7 @@
                   </a:txBody>
                   <a:tcPr>
                     <a:solidFill>
-                      <a:srgbClr val="FAF8F5"/>
+                      <a:srgbClr val="FFFFFF"/>
                     </a:solidFill>
                   </a:tcPr>
                 </a:tc>
@@ -7193,7 +7339,7 @@
                   </a:txBody>
                   <a:tcPr>
                     <a:solidFill>
-                      <a:srgbClr val="FAF8F5"/>
+                      <a:srgbClr val="FFFFFF"/>
                     </a:solidFill>
                   </a:tcPr>
                 </a:tc>
@@ -7217,7 +7363,7 @@
                   </a:txBody>
                   <a:tcPr>
                     <a:solidFill>
-                      <a:srgbClr val="FAF8F5"/>
+                      <a:srgbClr val="FFFFFF"/>
                     </a:solidFill>
                   </a:tcPr>
                 </a:tc>
@@ -7241,7 +7387,7 @@
                   </a:txBody>
                   <a:tcPr>
                     <a:solidFill>
-                      <a:srgbClr val="FAF8F5"/>
+                      <a:srgbClr val="FFFFFF"/>
                     </a:solidFill>
                   </a:tcPr>
                 </a:tc>
@@ -7265,12 +7411,12 @@
                   </a:txBody>
                   <a:tcPr>
                     <a:solidFill>
-                      <a:srgbClr val="FAF8F5"/>
+                      <a:srgbClr val="FFFFFF"/>
                     </a:solidFill>
                   </a:tcPr>
                 </a:tc>
               </a:tr>
-              <a:tr h="448887">
+              <a:tr h="411480">
                 <a:tc>
                   <a:txBody>
                     <a:bodyPr/>
@@ -7291,7 +7437,7 @@
                   </a:txBody>
                   <a:tcPr>
                     <a:solidFill>
-                      <a:srgbClr val="FFFFFF"/>
+                      <a:srgbClr val="FAF8F5"/>
                     </a:solidFill>
                   </a:tcPr>
                 </a:tc>
@@ -7315,7 +7461,7 @@
                   </a:txBody>
                   <a:tcPr>
                     <a:solidFill>
-                      <a:srgbClr val="FFFFFF"/>
+                      <a:srgbClr val="FAF8F5"/>
                     </a:solidFill>
                   </a:tcPr>
                 </a:tc>
@@ -7339,7 +7485,7 @@
                   </a:txBody>
                   <a:tcPr>
                     <a:solidFill>
-                      <a:srgbClr val="FFFFFF"/>
+                      <a:srgbClr val="FAF8F5"/>
                     </a:solidFill>
                   </a:tcPr>
                 </a:tc>
@@ -7363,7 +7509,7 @@
                   </a:txBody>
                   <a:tcPr>
                     <a:solidFill>
-                      <a:srgbClr val="FFFFFF"/>
+                      <a:srgbClr val="FAF8F5"/>
                     </a:solidFill>
                   </a:tcPr>
                 </a:tc>
@@ -7387,7 +7533,7 @@
                   </a:txBody>
                   <a:tcPr>
                     <a:solidFill>
-                      <a:srgbClr val="FFFFFF"/>
+                      <a:srgbClr val="FAF8F5"/>
                     </a:solidFill>
                   </a:tcPr>
                 </a:tc>
@@ -7411,12 +7557,12 @@
                   </a:txBody>
                   <a:tcPr>
                     <a:solidFill>
-                      <a:srgbClr val="FFFFFF"/>
+                      <a:srgbClr val="FAF8F5"/>
                     </a:solidFill>
                   </a:tcPr>
                 </a:tc>
               </a:tr>
-              <a:tr h="448887">
+              <a:tr h="411480">
                 <a:tc>
                   <a:txBody>
                     <a:bodyPr/>
@@ -7437,7 +7583,7 @@
                   </a:txBody>
                   <a:tcPr>
                     <a:solidFill>
-                      <a:srgbClr val="FAF8F5"/>
+                      <a:srgbClr val="FFFFFF"/>
                     </a:solidFill>
                   </a:tcPr>
                 </a:tc>
@@ -7461,7 +7607,7 @@
                   </a:txBody>
                   <a:tcPr>
                     <a:solidFill>
-                      <a:srgbClr val="FAF8F5"/>
+                      <a:srgbClr val="FFFFFF"/>
                     </a:solidFill>
                   </a:tcPr>
                 </a:tc>
@@ -7485,7 +7631,7 @@
                   </a:txBody>
                   <a:tcPr>
                     <a:solidFill>
-                      <a:srgbClr val="FAF8F5"/>
+                      <a:srgbClr val="FFFFFF"/>
                     </a:solidFill>
                   </a:tcPr>
                 </a:tc>
@@ -7509,7 +7655,7 @@
                   </a:txBody>
                   <a:tcPr>
                     <a:solidFill>
-                      <a:srgbClr val="FAF8F5"/>
+                      <a:srgbClr val="FFFFFF"/>
                     </a:solidFill>
                   </a:tcPr>
                 </a:tc>
@@ -7533,7 +7679,7 @@
                   </a:txBody>
                   <a:tcPr>
                     <a:solidFill>
-                      <a:srgbClr val="FAF8F5"/>
+                      <a:srgbClr val="FFFFFF"/>
                     </a:solidFill>
                   </a:tcPr>
                 </a:tc>
@@ -7545,7 +7691,7 @@
                       <a:pPr algn="ctr">
                         <a:defRPr sz="1000" b="1">
                           <a:solidFill>
-                            <a:srgbClr val="C62828"/>
+                            <a:srgbClr val="2E7D32"/>
                           </a:solidFill>
                           <a:latin typeface="Arial"/>
                         </a:defRPr>
@@ -7557,12 +7703,12 @@
                   </a:txBody>
                   <a:tcPr>
                     <a:solidFill>
-                      <a:srgbClr val="FAF8F5"/>
+                      <a:srgbClr val="FFFFFF"/>
                     </a:solidFill>
                   </a:tcPr>
                 </a:tc>
               </a:tr>
-              <a:tr h="448887">
+              <a:tr h="411480">
                 <a:tc>
                   <a:txBody>
                     <a:bodyPr/>
@@ -7583,7 +7729,7 @@
                   </a:txBody>
                   <a:tcPr>
                     <a:solidFill>
-                      <a:srgbClr val="FFFFFF"/>
+                      <a:srgbClr val="FAF8F5"/>
                     </a:solidFill>
                   </a:tcPr>
                 </a:tc>
@@ -7607,7 +7753,7 @@
                   </a:txBody>
                   <a:tcPr>
                     <a:solidFill>
-                      <a:srgbClr val="FFFFFF"/>
+                      <a:srgbClr val="FAF8F5"/>
                     </a:solidFill>
                   </a:tcPr>
                 </a:tc>
@@ -7631,7 +7777,7 @@
                   </a:txBody>
                   <a:tcPr>
                     <a:solidFill>
-                      <a:srgbClr val="FFFFFF"/>
+                      <a:srgbClr val="FAF8F5"/>
                     </a:solidFill>
                   </a:tcPr>
                 </a:tc>
@@ -7655,7 +7801,7 @@
                   </a:txBody>
                   <a:tcPr>
                     <a:solidFill>
-                      <a:srgbClr val="FFFFFF"/>
+                      <a:srgbClr val="FAF8F5"/>
                     </a:solidFill>
                   </a:tcPr>
                 </a:tc>
@@ -7679,7 +7825,7 @@
                   </a:txBody>
                   <a:tcPr>
                     <a:solidFill>
-                      <a:srgbClr val="FFFFFF"/>
+                      <a:srgbClr val="FAF8F5"/>
                     </a:solidFill>
                   </a:tcPr>
                 </a:tc>
@@ -7703,12 +7849,12 @@
                   </a:txBody>
                   <a:tcPr>
                     <a:solidFill>
-                      <a:srgbClr val="FFFFFF"/>
+                      <a:srgbClr val="FAF8F5"/>
                     </a:solidFill>
                   </a:tcPr>
                 </a:tc>
               </a:tr>
-              <a:tr h="448887">
+              <a:tr h="411480">
                 <a:tc>
                   <a:txBody>
                     <a:bodyPr/>
@@ -7729,7 +7875,7 @@
                   </a:txBody>
                   <a:tcPr>
                     <a:solidFill>
-                      <a:srgbClr val="FAF8F5"/>
+                      <a:srgbClr val="FFFFFF"/>
                     </a:solidFill>
                   </a:tcPr>
                 </a:tc>
@@ -7753,7 +7899,7 @@
                   </a:txBody>
                   <a:tcPr>
                     <a:solidFill>
-                      <a:srgbClr val="FAF8F5"/>
+                      <a:srgbClr val="FFFFFF"/>
                     </a:solidFill>
                   </a:tcPr>
                 </a:tc>
@@ -7777,7 +7923,7 @@
                   </a:txBody>
                   <a:tcPr>
                     <a:solidFill>
-                      <a:srgbClr val="FAF8F5"/>
+                      <a:srgbClr val="FFFFFF"/>
                     </a:solidFill>
                   </a:tcPr>
                 </a:tc>
@@ -7801,7 +7947,7 @@
                   </a:txBody>
                   <a:tcPr>
                     <a:solidFill>
-                      <a:srgbClr val="FAF8F5"/>
+                      <a:srgbClr val="FFFFFF"/>
                     </a:solidFill>
                   </a:tcPr>
                 </a:tc>
@@ -7825,7 +7971,7 @@
                   </a:txBody>
                   <a:tcPr>
                     <a:solidFill>
-                      <a:srgbClr val="FAF8F5"/>
+                      <a:srgbClr val="FFFFFF"/>
                     </a:solidFill>
                   </a:tcPr>
                 </a:tc>
@@ -7837,7 +7983,7 @@
                       <a:pPr algn="ctr">
                         <a:defRPr sz="1000" b="1">
                           <a:solidFill>
-                            <a:srgbClr val="C62828"/>
+                            <a:srgbClr val="2E7D32"/>
                           </a:solidFill>
                           <a:latin typeface="Arial"/>
                         </a:defRPr>
@@ -7849,12 +7995,12 @@
                   </a:txBody>
                   <a:tcPr>
                     <a:solidFill>
-                      <a:srgbClr val="FAF8F5"/>
+                      <a:srgbClr val="FFFFFF"/>
                     </a:solidFill>
                   </a:tcPr>
                 </a:tc>
               </a:tr>
-              <a:tr h="448890">
+              <a:tr h="411480">
                 <a:tc>
                   <a:txBody>
                     <a:bodyPr/>
@@ -7875,7 +8021,7 @@
                   </a:txBody>
                   <a:tcPr>
                     <a:solidFill>
-                      <a:srgbClr val="FFFFFF"/>
+                      <a:srgbClr val="FAF8F5"/>
                     </a:solidFill>
                   </a:tcPr>
                 </a:tc>
@@ -7899,7 +8045,7 @@
                   </a:txBody>
                   <a:tcPr>
                     <a:solidFill>
-                      <a:srgbClr val="FFFFFF"/>
+                      <a:srgbClr val="FAF8F5"/>
                     </a:solidFill>
                   </a:tcPr>
                 </a:tc>
@@ -7923,7 +8069,7 @@
                   </a:txBody>
                   <a:tcPr>
                     <a:solidFill>
-                      <a:srgbClr val="FFFFFF"/>
+                      <a:srgbClr val="FAF8F5"/>
                     </a:solidFill>
                   </a:tcPr>
                 </a:tc>
@@ -7947,7 +8093,7 @@
                   </a:txBody>
                   <a:tcPr>
                     <a:solidFill>
-                      <a:srgbClr val="FFFFFF"/>
+                      <a:srgbClr val="FAF8F5"/>
                     </a:solidFill>
                   </a:tcPr>
                 </a:tc>
@@ -7971,7 +8117,7 @@
                   </a:txBody>
                   <a:tcPr>
                     <a:solidFill>
-                      <a:srgbClr val="FFFFFF"/>
+                      <a:srgbClr val="FAF8F5"/>
                     </a:solidFill>
                   </a:tcPr>
                 </a:tc>
@@ -7995,7 +8141,7 @@
                   </a:txBody>
                   <a:tcPr>
                     <a:solidFill>
-                      <a:srgbClr val="FFFFFF"/>
+                      <a:srgbClr val="FAF8F5"/>
                     </a:solidFill>
                   </a:tcPr>
                 </a:tc>

</xml_diff>

<commit_message>
Add official Page 11 Bank Balances Analysis & Opening Balances table and Page 12 Income vs Expense Growth Hero Overview across all deliverables
</commit_message>
<xml_diff>
--- a/التقرير_الاحترافي_المطور/عرض_تقديمي_جمعية_طبيبي_النصف_سنوي_٢٠٢٦.pptx
+++ b/التقرير_الاحترافي_المطور/عرض_تقديمي_جمعية_طبيبي_النصف_سنوي_٢٠٢٦.pptx
@@ -9240,38 +9240,45 @@
               </a:defRPr>
             </a:pPr>
             <a:r>
-              <a:t>• إجمالي النقدية بالبنوك: ١,٠٠١,٧٥٤ ريال</a:t>
+              <a:t>• إجمالي النقدية بالبنوك: ١,٠٠١,٧٥٤ ريال (الأهلي: ٩٣٠,٧٠٢ | الراجحي: ٧١,٠٥٢)</a:t>
             </a:r>
             <a:br/>
             <a:r>
-              <a:t>  - البنك الأهلي: ٩٣٠,٧٠٢ ريال</a:t>
-            </a:r>
-            <a:br/>
-            <a:r>
-              <a:t>  - مصرف الراجحي: ٧١,٠٥٢ ريال</a:t>
+              <a:t>• الأرصدة الافتتاحية المرحّلة من ٢٠٢٥م: ٨٤٩,٤٢١ ريال (الأهلي: ٨٤٨,٨٢٠ | الراجحي: ٦٠١)</a:t>
             </a:r>
             <a:br/>
             <a:br/>
             <a:r>
-              <a:t>• هيكل الأموال المتاحة:</a:t>
+              <a:t>• تحليل قيود الأرصدة (ص ١١):</a:t>
             </a:r>
             <a:br/>
             <a:r>
-              <a:t>  - أموال مقيدة (زكاة وعلاج): ٣٦٧,٠٩٣ ريال</a:t>
+              <a:t>  - العلاج (مقيد): ٣٦٧,٠٩٣ ريال (يشمل ٢٥٠ ألف دعم إحسان لأورام)</a:t>
             </a:r>
             <a:br/>
             <a:r>
-              <a:t>  - أموال غير مقيدة: ٦٣٤,٦٦١ ريال</a:t>
+              <a:t>  - التبرعات والدعم العام: ٦١٦,٦٦١ ريال</a:t>
+            </a:r>
+            <a:br/>
+            <a:r>
+              <a:t>  - اشتراكات العضوية: ١٨,٠٠٠ ريال</a:t>
             </a:r>
             <a:br/>
             <a:br/>
             <a:r>
-              <a:t>• كفاية الاحتياطي النقدي: تغطية المصروفات التشغيلية لمدة ١٢ شهراً.</a:t>
+              <a:t>• كفاءة الدخل والمصروفات (ص ١٢):</a:t>
             </a:r>
             <a:br/>
+            <a:r>
+              <a:t>  - إجمالي الدخل: ٥٨٢,١٦٧ ريال (+١٩٢٪)</a:t>
+            </a:r>
             <a:br/>
             <a:r>
-              <a:t>• مخاطر التركز: تبرع واحد من فاعل خير بـ ٢٥٠ ألف ريال يمثل ٤٣٪ من إجمالي الدخل.</a:t>
+              <a:t>  - إجمالي المصروفات: ٢٤٩,٢٧٤ ريال</a:t>
+            </a:r>
+            <a:br/>
+            <a:r>
+              <a:t>  - صافي الأصول بالمركز المالي: ٩٧٢,٧١٣ ريال</a:t>
             </a:r>
           </a:p>
         </p:txBody>

</xml_diff>